<commit_message>
Add Hangul onboarding, AI lesson authoring, and flashcards revamp
- Hangul onboarding flow and curriculum v2 availability gating
- AI-assisted curriculum lesson authoring + pattern lessons (topic, subject, identification, existence, location)
- Curriculum version modal and useCurriculumVersion hook
- PlayableKorean component; flashcards page overhaul
- Schema, user, and route updates supporting the above

Co-Authored-By: Claude Opus 4.8 (1M context) <noreply@anthropic.com>
</commit_message>
<xml_diff>
--- a/kumoh-pilot/Kumoh_Pitch_Deck.pptx
+++ b/kumoh-pilot/Kumoh_Pitch_Deck.pptx
@@ -141,7 +141,7 @@
                 </a:solidFill>
                 <a:latin typeface="Arial"/>
               </a:rPr>
-              <a:t>Pilot cost by track: list vs discount (USD, Institution Pro)</a:t>
+              <a:t>Pilot cost by track — list vs discount (USD, Institution Pro)</a:t>
             </a:r>
           </a:p>
         </c:rich>
@@ -1815,7 +1815,7 @@
                 <a:ea typeface="Arial" pitchFamily="34" charset="-122"/>
                 <a:cs typeface="Arial" pitchFamily="34" charset="-120"/>
               </a:rPr>
-              <a:t/>
+              <a:t>LINGO </a:t>
             </a:r>
             <a:r>
               <a:rPr lang="en-US" sz="1800" b="1" kern="0" spc="500" dirty="0">
@@ -1826,7 +1826,7 @@
                 <a:ea typeface="Arial" pitchFamily="34" charset="-122"/>
                 <a:cs typeface="Arial" pitchFamily="34" charset="-120"/>
               </a:rPr>
-              <a:t/>
+              <a:t>BOOTH</a:t>
             </a:r>
             <a:endParaRPr lang="en-US" sz="1800" dirty="0"/>
           </a:p>
@@ -1979,7 +1979,7 @@
                 <a:ea typeface="Arial" pitchFamily="34" charset="-122"/>
                 <a:cs typeface="Arial" pitchFamily="34" charset="-120"/>
               </a:rPr>
-              <a:t>Kumoh National Institute of Technology, International Programs &amp; Language Education Center</a:t>
+              <a:t>Kumoh National Institute of Technology — International Programs &amp; Language Education Center</a:t>
             </a:r>
             <a:endParaRPr lang="en-US" sz="1800" dirty="0"/>
           </a:p>
@@ -2018,80 +2018,12 @@
                 <a:ea typeface="Arial" pitchFamily="34" charset="-122"/>
                 <a:cs typeface="Arial" pitchFamily="34" charset="-120"/>
               </a:rPr>
-              <a:t>Dr Ikechi Saviour Igboanusi (PhD)  ·  June 2026</a:t>
+              <a:t>Ikechi Saviour Igboanusi  ·  June 2026</a:t>
             </a:r>
             <a:endParaRPr lang="en-US" sz="1200" dirty="0"/>
           </a:p>
         </p:txBody>
       </p:sp>
-      <p:sp>
-        <p:nvSpPr>
-          <p:cNvPr id="10" name="Rounded Rectangle 9"/>
-          <p:cNvSpPr/>
-          <p:nvPr/>
-        </p:nvSpPr>
-        <p:spPr>
-          <a:xfrm>
-            <a:off x="731520" y="1078992"/>
-            <a:ext cx="2286000" cy="676656"/>
-          </a:xfrm>
-          <a:prstGeom prst="roundRect">
-            <a:avLst/>
-          </a:prstGeom>
-          <a:solidFill>
-            <a:srgbClr val="FFFFFF"/>
-          </a:solidFill>
-          <a:ln>
-            <a:noFill/>
-          </a:ln>
-          <a:effectLst/>
-        </p:spPr>
-        <p:style>
-          <a:lnRef idx="1">
-            <a:schemeClr val="accent1"/>
-          </a:lnRef>
-          <a:fillRef idx="3">
-            <a:schemeClr val="accent1"/>
-          </a:fillRef>
-          <a:effectRef idx="2">
-            <a:schemeClr val="accent1"/>
-          </a:effectRef>
-          <a:fontRef idx="minor">
-            <a:schemeClr val="lt1"/>
-          </a:fontRef>
-        </p:style>
-        <p:txBody>
-          <a:bodyPr rtlCol="0" anchor="ctr"/>
-          <a:lstStyle/>
-          <a:p>
-            <a:pPr algn="ctr"/>
-          </a:p>
-        </p:txBody>
-      </p:sp>
-      <p:pic>
-        <p:nvPicPr>
-          <p:cNvPr id="11" name="Picture 10" descr="_logo_lockup.png"/>
-          <p:cNvPicPr>
-            <a:picLocks noChangeAspect="1"/>
-          </p:cNvPicPr>
-          <p:nvPr/>
-        </p:nvPicPr>
-        <p:blipFill>
-          <a:blip r:embed="rId4"/>
-          <a:stretch>
-            <a:fillRect/>
-          </a:stretch>
-        </p:blipFill>
-        <p:spPr>
-          <a:xfrm>
-            <a:off x="886968" y="1207008"/>
-            <a:ext cx="1860760" cy="420624"/>
-          </a:xfrm>
-          <a:prstGeom prst="rect">
-            <a:avLst/>
-          </a:prstGeom>
-        </p:spPr>
-      </p:pic>
     </p:spTree>
   </p:cSld>
   <p:clrMapOvr>
@@ -2542,7 +2474,7 @@
                 <a:ea typeface="Arial" pitchFamily="34" charset="-122"/>
                 <a:cs typeface="Arial" pitchFamily="34" charset="-120"/>
               </a:rPr>
-              <a:t>Issue a Purchase Order, we provision seats and onboard your team</a:t>
+              <a:t>Issue a Purchase Order — we provision seats and onboard your team</a:t>
             </a:r>
             <a:endParaRPr lang="en-US" sz="1700" dirty="0"/>
           </a:p>
@@ -2596,9 +2528,6 @@
           <a:bodyPr wrap="square" lIns="0" tIns="0" rIns="0" bIns="0" rtlCol="0" anchor="ctr"/>
           <a:lstStyle/>
           <a:p>
-            <a:pPr marL="0" indent="0">
-              <a:buNone/>
-            </a:pPr>
             <a:r>
               <a:rPr lang="en-US" sz="1300" b="1" dirty="0">
                 <a:solidFill>
@@ -2641,7 +2570,29 @@
                 <a:ea typeface="Arial" pitchFamily="34" charset="-122"/>
                 <a:cs typeface="Arial" pitchFamily="34" charset="-120"/>
               </a:rPr>
-              <a:t>   ·   Lingo Booth</a:t>
+              <a:t>  ·   Lingo Booth  ·   </a:t>
+            </a:r>
+            <a:r>
+              <a:rPr lang="en-US" sz="1300" dirty="0" err="1">
+                <a:solidFill>
+                  <a:srgbClr val="9DB98A"/>
+                </a:solidFill>
+                <a:latin typeface="Arial" pitchFamily="34" charset="0"/>
+                <a:ea typeface="Arial" pitchFamily="34" charset="-122"/>
+                <a:cs typeface="Arial" pitchFamily="34" charset="-120"/>
+              </a:rPr>
+              <a:t>lingobooth.com</a:t>
+            </a:r>
+            <a:r>
+              <a:rPr lang="en-US" sz="1300" dirty="0">
+                <a:solidFill>
+                  <a:srgbClr val="9DB98A"/>
+                </a:solidFill>
+                <a:latin typeface="Arial" pitchFamily="34" charset="0"/>
+                <a:ea typeface="Arial" pitchFamily="34" charset="-122"/>
+                <a:cs typeface="Arial" pitchFamily="34" charset="-120"/>
+              </a:rPr>
+              <a:t> </a:t>
             </a:r>
             <a:endParaRPr lang="en-US" sz="1300" dirty="0"/>
           </a:p>
@@ -3049,7 +3000,7 @@
         <p:spPr>
           <a:xfrm>
             <a:off x="6537960" y="2103120"/>
-            <a:ext cx="1371600" cy="384048"/>
+            <a:ext cx="1781868" cy="384048"/>
           </a:xfrm>
           <a:prstGeom prst="rect">
             <a:avLst/>
@@ -3076,7 +3027,7 @@
         <p:spPr>
           <a:xfrm>
             <a:off x="6537960" y="2103120"/>
-            <a:ext cx="1371600" cy="384048"/>
+            <a:ext cx="1781868" cy="384048"/>
           </a:xfrm>
           <a:prstGeom prst="rect">
             <a:avLst/>
@@ -3100,7 +3051,7 @@
                 <a:ea typeface="Arial" pitchFamily="34" charset="-122"/>
                 <a:cs typeface="Arial" pitchFamily="34" charset="-120"/>
               </a:rPr>
-              <a:t>ALSO THIS FALL</a:t>
+              <a:t>ALSO, THIS FALL</a:t>
             </a:r>
             <a:endParaRPr lang="en-US" sz="1000" dirty="0"/>
           </a:p>
@@ -3231,7 +3182,7 @@
                 <a:ea typeface="Arial" pitchFamily="34" charset="-122"/>
                 <a:cs typeface="Arial" pitchFamily="34" charset="-120"/>
               </a:rPr>
-              <a:t>run both tracks this fall, with the graduate evening classes as our priority and the language program in parallel.</a:t>
+              <a:t>run both tracks this fall — with the graduate evening classes as our priority and the language program in parallel.</a:t>
             </a:r>
             <a:endParaRPr lang="en-US" sz="1500" dirty="0"/>
           </a:p>
@@ -3489,7 +3440,7 @@
                 <a:ea typeface="Arial" pitchFamily="34" charset="-122"/>
                 <a:cs typeface="Arial" pitchFamily="34" charset="-120"/>
               </a:rPr>
-              <a:t>Only ~2 sessions a week, so a self-study companion extends class time without adding teaching hours.</a:t>
+              <a:t>Only ~2 sessions a week — a self-study companion extends class time without adding teaching hours.</a:t>
             </a:r>
             <a:endParaRPr lang="en-US" sz="1300" dirty="0"/>
           </a:p>
@@ -5479,7 +5430,7 @@
                 </a:solidFill>
                 <a:latin typeface="Arial"/>
               </a:rPr>
-              <a:t>FOR THE CENTER · INSTITUTION ADMIN</a:t>
+              <a:t>FOR THE CENTER — INSTITUTION ADMIN</a:t>
             </a:r>
           </a:p>
         </p:txBody>
@@ -6577,7 +6528,7 @@
                 </a:solidFill>
                 <a:latin typeface="Arial"/>
               </a:rPr>
-              <a:t>Coordinators manage everything from one dashboard, with no spreadsheets or manual seat tracking.</a:t>
+              <a:t>Coordinators manage everything from one dashboard — no spreadsheets, no manual seat tracking.</a:t>
             </a:r>
           </a:p>
         </p:txBody>
@@ -7605,7 +7556,7 @@
                 <a:ea typeface="Arial" pitchFamily="34" charset="-122"/>
                 <a:cs typeface="Arial" pitchFamily="34" charset="-120"/>
               </a:rPr>
-              <a:t>TWO-TRACK PRICING</a:t>
+              <a:t>PRICING — TWO TRACKS</a:t>
             </a:r>
             <a:endParaRPr lang="en-US" sz="1200" dirty="0"/>
           </a:p>
@@ -8235,7 +8186,7 @@
                 <a:ea typeface="Arial" pitchFamily="34" charset="-122"/>
                 <a:cs typeface="Arial" pitchFamily="34" charset="-120"/>
               </a:rPr>
-              <a:t>Next semester (Sep-Dec, 2026)</a:t>
+              <a:t>Next semester (Sep–Dec, 2026)</a:t>
             </a:r>
             <a:endParaRPr lang="en-US" sz="1200" dirty="0"/>
           </a:p>
@@ -8460,7 +8411,7 @@
                 <a:ea typeface="Arial" pitchFamily="34" charset="-122"/>
                 <a:cs typeface="Arial" pitchFamily="34" charset="-120"/>
               </a:rPr>
-              <a:t>This fall · Sep-Feb (two semesters)</a:t>
+              <a:t>This fall · Sep–Feb (two semesters)</a:t>
             </a:r>
             <a:endParaRPr lang="en-US" sz="1200" dirty="0"/>
           </a:p>

</xml_diff>